<commit_message>
Make server port configurable via PORT env
Read PORT from the environment across the app and container. Dockerfile: add ENV PORT=7860. gunicorn_conf.py: import os, read PORT (default 7860), set workers/threads and bind to 0.0.0.0:{PORT}. run.py: import os, read PORT and DEBUG env vars and use them when running the app. Also update binary presentation file.
</commit_message>
<xml_diff>
--- a/Présentation_orale.pptx
+++ b/Présentation_orale.pptx
@@ -6,9 +6,10 @@
   </p:sldMasterIdLst>
   <p:sldIdLst>
     <p:sldId id="256" r:id="rId2"/>
-    <p:sldId id="257" r:id="rId3"/>
-    <p:sldId id="258" r:id="rId4"/>
-    <p:sldId id="259" r:id="rId5"/>
+    <p:sldId id="258" r:id="rId3"/>
+    <p:sldId id="257" r:id="rId4"/>
+    <p:sldId id="260" r:id="rId5"/>
+    <p:sldId id="259" r:id="rId6"/>
   </p:sldIdLst>
   <p:sldSz cx="12192000" cy="6858000"/>
   <p:notesSz cx="6858000" cy="9144000"/>
@@ -3332,58 +3333,6 @@
           <a:chExt cx="0" cy="0"/>
         </a:xfrm>
       </p:grpSpPr>
-      <p:sp>
-        <p:nvSpPr>
-          <p:cNvPr id="2" name="Rectangle 1">
-            <a:extLst>
-              <a:ext uri="{FF2B5EF4-FFF2-40B4-BE49-F238E27FC236}">
-                <a16:creationId xmlns:a16="http://schemas.microsoft.com/office/drawing/2014/main" id="{62760315-6D89-75DB-B926-D2D7E4A39A99}"/>
-              </a:ext>
-            </a:extLst>
-          </p:cNvPr>
-          <p:cNvSpPr/>
-          <p:nvPr/>
-        </p:nvSpPr>
-        <p:spPr>
-          <a:xfrm>
-            <a:off x="1" y="0"/>
-            <a:ext cx="12192000" cy="1428557"/>
-          </a:xfrm>
-          <a:prstGeom prst="rect">
-            <a:avLst/>
-          </a:prstGeom>
-          <a:solidFill>
-            <a:srgbClr val="232F3E"/>
-          </a:solidFill>
-          <a:ln>
-            <a:noFill/>
-          </a:ln>
-        </p:spPr>
-        <p:style>
-          <a:lnRef idx="2">
-            <a:schemeClr val="accent1">
-              <a:shade val="15000"/>
-            </a:schemeClr>
-          </a:lnRef>
-          <a:fillRef idx="1">
-            <a:schemeClr val="accent1"/>
-          </a:fillRef>
-          <a:effectRef idx="0">
-            <a:schemeClr val="accent1"/>
-          </a:effectRef>
-          <a:fontRef idx="minor">
-            <a:schemeClr val="lt1"/>
-          </a:fontRef>
-        </p:style>
-        <p:txBody>
-          <a:bodyPr rtlCol="0" anchor="ctr"/>
-          <a:lstStyle/>
-          <a:p>
-            <a:pPr algn="ctr"/>
-            <a:endParaRPr lang="fr-FR"/>
-          </a:p>
-        </p:txBody>
-      </p:sp>
       <p:cxnSp>
         <p:nvCxnSpPr>
           <p:cNvPr id="8" name="Connecteur droit 7">
@@ -3400,8 +3349,8 @@
         </p:nvCxnSpPr>
         <p:spPr>
           <a:xfrm>
-            <a:off x="447040" y="3140561"/>
-            <a:ext cx="5130800" cy="0"/>
+            <a:off x="2738120" y="1596946"/>
+            <a:ext cx="6170070" cy="0"/>
           </a:xfrm>
           <a:prstGeom prst="line">
             <a:avLst/>
@@ -3441,8 +3390,8 @@
         </p:nvSpPr>
         <p:spPr>
           <a:xfrm>
-            <a:off x="0" y="1940232"/>
-            <a:ext cx="7345680" cy="1200329"/>
+            <a:off x="1425677" y="396617"/>
+            <a:ext cx="9340645" cy="1200329"/>
           </a:xfrm>
           <a:prstGeom prst="rect">
             <a:avLst/>
@@ -3459,7 +3408,7 @@
               <a:rPr lang="fr-FR" sz="7200" dirty="0">
                 <a:latin typeface="Abadi" panose="020B0604020104020204" pitchFamily="34" charset="0"/>
               </a:rPr>
-              <a:t>TITRE DE ZINZIN</a:t>
+              <a:t>Challenge Web Mining</a:t>
             </a:r>
           </a:p>
         </p:txBody>
@@ -3585,6 +3534,333 @@
         <p:cNvPr id="1" name="">
           <a:extLst>
             <a:ext uri="{FF2B5EF4-FFF2-40B4-BE49-F238E27FC236}">
+              <a16:creationId xmlns:a16="http://schemas.microsoft.com/office/drawing/2014/main" id="{CD2158CB-32A2-6844-FCEA-CA2E7B158AFE}"/>
+            </a:ext>
+          </a:extLst>
+        </p:cNvPr>
+        <p:cNvGrpSpPr/>
+        <p:nvPr/>
+      </p:nvGrpSpPr>
+      <p:grpSpPr>
+        <a:xfrm>
+          <a:off x="0" y="0"/>
+          <a:ext cx="0" cy="0"/>
+          <a:chOff x="0" y="0"/>
+          <a:chExt cx="0" cy="0"/>
+        </a:xfrm>
+      </p:grpSpPr>
+      <p:sp>
+        <p:nvSpPr>
+          <p:cNvPr id="2" name="Rectangle 1">
+            <a:extLst>
+              <a:ext uri="{FF2B5EF4-FFF2-40B4-BE49-F238E27FC236}">
+                <a16:creationId xmlns:a16="http://schemas.microsoft.com/office/drawing/2014/main" id="{95554FFE-D381-4503-F280-79225A351A02}"/>
+              </a:ext>
+            </a:extLst>
+          </p:cNvPr>
+          <p:cNvSpPr/>
+          <p:nvPr/>
+        </p:nvSpPr>
+        <p:spPr>
+          <a:xfrm>
+            <a:off x="0" y="1"/>
+            <a:ext cx="6794090" cy="6858000"/>
+          </a:xfrm>
+          <a:prstGeom prst="rect">
+            <a:avLst/>
+          </a:prstGeom>
+          <a:solidFill>
+            <a:srgbClr val="FF9A00"/>
+          </a:solidFill>
+          <a:ln>
+            <a:noFill/>
+          </a:ln>
+        </p:spPr>
+        <p:style>
+          <a:lnRef idx="2">
+            <a:schemeClr val="accent1">
+              <a:shade val="15000"/>
+            </a:schemeClr>
+          </a:lnRef>
+          <a:fillRef idx="1">
+            <a:schemeClr val="accent1"/>
+          </a:fillRef>
+          <a:effectRef idx="0">
+            <a:schemeClr val="accent1"/>
+          </a:effectRef>
+          <a:fontRef idx="minor">
+            <a:schemeClr val="lt1"/>
+          </a:fontRef>
+        </p:style>
+        <p:txBody>
+          <a:bodyPr rtlCol="0" anchor="ctr"/>
+          <a:lstStyle/>
+          <a:p>
+            <a:pPr algn="ctr"/>
+            <a:endParaRPr lang="fr-FR"/>
+          </a:p>
+        </p:txBody>
+      </p:sp>
+      <p:sp>
+        <p:nvSpPr>
+          <p:cNvPr id="3" name="ZoneTexte 2">
+            <a:extLst>
+              <a:ext uri="{FF2B5EF4-FFF2-40B4-BE49-F238E27FC236}">
+                <a16:creationId xmlns:a16="http://schemas.microsoft.com/office/drawing/2014/main" id="{066412E1-CC1C-A442-9B30-2E3C18DFDE28}"/>
+              </a:ext>
+            </a:extLst>
+          </p:cNvPr>
+          <p:cNvSpPr txBox="1"/>
+          <p:nvPr/>
+        </p:nvSpPr>
+        <p:spPr>
+          <a:xfrm>
+            <a:off x="761097" y="1808446"/>
+            <a:ext cx="9340645" cy="1200329"/>
+          </a:xfrm>
+          <a:prstGeom prst="rect">
+            <a:avLst/>
+          </a:prstGeom>
+          <a:noFill/>
+          <a:ln w="47625">
+            <a:solidFill>
+              <a:schemeClr val="tx1"/>
+            </a:solidFill>
+          </a:ln>
+        </p:spPr>
+        <p:txBody>
+          <a:bodyPr wrap="square" rtlCol="0">
+            <a:spAutoFit/>
+          </a:bodyPr>
+          <a:lstStyle/>
+          <a:p>
+            <a:r>
+              <a:rPr lang="fr-FR" sz="7200" dirty="0">
+                <a:latin typeface="Abadi" panose="020B0604020104020204" pitchFamily="34" charset="0"/>
+              </a:rPr>
+              <a:t>Challenge Web Mining</a:t>
+            </a:r>
+          </a:p>
+        </p:txBody>
+      </p:sp>
+      <p:pic>
+        <p:nvPicPr>
+          <p:cNvPr id="4" name="Picture 2">
+            <a:extLst>
+              <a:ext uri="{FF2B5EF4-FFF2-40B4-BE49-F238E27FC236}">
+                <a16:creationId xmlns:a16="http://schemas.microsoft.com/office/drawing/2014/main" id="{157DF6AB-E208-A704-AD45-D450ECB260AA}"/>
+              </a:ext>
+            </a:extLst>
+          </p:cNvPr>
+          <p:cNvPicPr>
+            <a:picLocks noChangeAspect="1" noChangeArrowheads="1"/>
+          </p:cNvPicPr>
+          <p:nvPr/>
+        </p:nvPicPr>
+        <p:blipFill>
+          <a:blip r:embed="rId2">
+            <a:extLst>
+              <a:ext uri="{28A0092B-C50C-407E-A947-70E740481C1C}">
+                <a14:useLocalDpi xmlns:a14="http://schemas.microsoft.com/office/drawing/2010/main" val="0"/>
+              </a:ext>
+            </a:extLst>
+          </a:blip>
+          <a:srcRect/>
+          <a:stretch>
+            <a:fillRect/>
+          </a:stretch>
+        </p:blipFill>
+        <p:spPr bwMode="auto">
+          <a:xfrm>
+            <a:off x="0" y="5134611"/>
+            <a:ext cx="3215481" cy="1723389"/>
+          </a:xfrm>
+          <a:prstGeom prst="rect">
+            <a:avLst/>
+          </a:prstGeom>
+          <a:noFill/>
+          <a:extLst>
+            <a:ext uri="{909E8E84-426E-40DD-AFC4-6F175D3DCCD1}">
+              <a14:hiddenFill xmlns:a14="http://schemas.microsoft.com/office/drawing/2010/main">
+                <a:solidFill>
+                  <a:srgbClr val="FFFFFF"/>
+                </a:solidFill>
+              </a14:hiddenFill>
+            </a:ext>
+          </a:extLst>
+        </p:spPr>
+      </p:pic>
+      <p:sp>
+        <p:nvSpPr>
+          <p:cNvPr id="5" name="ZoneTexte 4">
+            <a:extLst>
+              <a:ext uri="{FF2B5EF4-FFF2-40B4-BE49-F238E27FC236}">
+                <a16:creationId xmlns:a16="http://schemas.microsoft.com/office/drawing/2014/main" id="{8D1DA2CD-C8B5-E9C1-BA4A-BE165F26E6AA}"/>
+              </a:ext>
+            </a:extLst>
+          </p:cNvPr>
+          <p:cNvSpPr txBox="1"/>
+          <p:nvPr/>
+        </p:nvSpPr>
+        <p:spPr>
+          <a:xfrm>
+            <a:off x="9259746" y="5534640"/>
+            <a:ext cx="2673753" cy="923330"/>
+          </a:xfrm>
+          <a:prstGeom prst="rect">
+            <a:avLst/>
+          </a:prstGeom>
+          <a:noFill/>
+        </p:spPr>
+        <p:txBody>
+          <a:bodyPr wrap="square" rtlCol="0">
+            <a:spAutoFit/>
+          </a:bodyPr>
+          <a:lstStyle/>
+          <a:p>
+            <a:pPr algn="r"/>
+            <a:r>
+              <a:rPr lang="fr-FR" dirty="0"/>
+              <a:t>Olivier BOROT</a:t>
+            </a:r>
+          </a:p>
+          <a:p>
+            <a:pPr algn="r"/>
+            <a:r>
+              <a:rPr lang="fr-FR" dirty="0"/>
+              <a:t> Marin NAGY</a:t>
+            </a:r>
+          </a:p>
+          <a:p>
+            <a:pPr algn="r"/>
+            <a:r>
+              <a:rPr lang="fr-FR" dirty="0"/>
+              <a:t>  Léo-Paul </a:t>
+            </a:r>
+            <a:r>
+              <a:rPr lang="fr-FR" dirty="0" err="1"/>
+              <a:t>Knoepffler</a:t>
+            </a:r>
+            <a:endParaRPr lang="fr-FR" dirty="0"/>
+          </a:p>
+        </p:txBody>
+      </p:sp>
+      <p:sp>
+        <p:nvSpPr>
+          <p:cNvPr id="6" name="ZoneTexte 5">
+            <a:extLst>
+              <a:ext uri="{FF2B5EF4-FFF2-40B4-BE49-F238E27FC236}">
+                <a16:creationId xmlns:a16="http://schemas.microsoft.com/office/drawing/2014/main" id="{E50BB30C-669B-CEC1-6F48-E0AA0B225A23}"/>
+              </a:ext>
+            </a:extLst>
+          </p:cNvPr>
+          <p:cNvSpPr txBox="1"/>
+          <p:nvPr/>
+        </p:nvSpPr>
+        <p:spPr>
+          <a:xfrm>
+            <a:off x="8866208" y="5134611"/>
+            <a:ext cx="3067291" cy="369332"/>
+          </a:xfrm>
+          <a:prstGeom prst="rect">
+            <a:avLst/>
+          </a:prstGeom>
+          <a:noFill/>
+        </p:spPr>
+        <p:txBody>
+          <a:bodyPr wrap="square" rtlCol="0">
+            <a:spAutoFit/>
+          </a:bodyPr>
+          <a:lstStyle/>
+          <a:p>
+            <a:pPr algn="r"/>
+            <a:r>
+              <a:rPr lang="fr-FR" dirty="0"/>
+              <a:t>Master 2 SISE – Mars 2026</a:t>
+            </a:r>
+          </a:p>
+        </p:txBody>
+      </p:sp>
+      <p:sp>
+        <p:nvSpPr>
+          <p:cNvPr id="10" name="ZoneTexte 9">
+            <a:extLst>
+              <a:ext uri="{FF2B5EF4-FFF2-40B4-BE49-F238E27FC236}">
+                <a16:creationId xmlns:a16="http://schemas.microsoft.com/office/drawing/2014/main" id="{F103A600-69B4-B252-640A-455117B85992}"/>
+              </a:ext>
+            </a:extLst>
+          </p:cNvPr>
+          <p:cNvSpPr txBox="1"/>
+          <p:nvPr/>
+        </p:nvSpPr>
+        <p:spPr>
+          <a:xfrm>
+            <a:off x="761097" y="3333293"/>
+            <a:ext cx="5972538" cy="830997"/>
+          </a:xfrm>
+          <a:prstGeom prst="rect">
+            <a:avLst/>
+          </a:prstGeom>
+          <a:noFill/>
+          <a:ln w="47625">
+            <a:noFill/>
+          </a:ln>
+        </p:spPr>
+        <p:txBody>
+          <a:bodyPr wrap="square" rtlCol="0">
+            <a:spAutoFit/>
+          </a:bodyPr>
+          <a:lstStyle>
+            <a:defPPr>
+              <a:defRPr lang="fr-FR"/>
+            </a:defPPr>
+            <a:lvl1pPr>
+              <a:defRPr sz="7200">
+                <a:latin typeface="Abadi" panose="020B0604020104020204" pitchFamily="34" charset="0"/>
+              </a:defRPr>
+            </a:lvl1pPr>
+          </a:lstStyle>
+          <a:p>
+            <a:r>
+              <a:rPr lang="fr-FR" sz="2400" dirty="0"/>
+              <a:t>Analyses des comportements via les mouvements de souris sur un site marchand</a:t>
+            </a:r>
+          </a:p>
+        </p:txBody>
+      </p:sp>
+    </p:spTree>
+    <p:extLst>
+      <p:ext uri="{BB962C8B-B14F-4D97-AF65-F5344CB8AC3E}">
+        <p14:creationId xmlns:p14="http://schemas.microsoft.com/office/powerpoint/2010/main" val="1029189622"/>
+      </p:ext>
+    </p:extLst>
+  </p:cSld>
+  <p:clrMapOvr>
+    <a:masterClrMapping/>
+  </p:clrMapOvr>
+  <mc:AlternateContent xmlns:mc="http://schemas.openxmlformats.org/markup-compatibility/2006" xmlns:p159="http://schemas.microsoft.com/office/powerpoint/2015/09/main">
+    <mc:Choice Requires="p159">
+      <p:transition spd="med">
+        <p159:morph option="byObject"/>
+      </p:transition>
+    </mc:Choice>
+    <mc:Fallback xmlns="">
+      <p:transition spd="med">
+        <p:fade/>
+      </p:transition>
+    </mc:Fallback>
+  </mc:AlternateContent>
+</p:sld>
+</file>
+
+<file path=ppt/slides/slide3.xml><?xml version="1.0" encoding="utf-8"?>
+<p:sld xmlns:a="http://schemas.openxmlformats.org/drawingml/2006/main" xmlns:r="http://schemas.openxmlformats.org/officeDocument/2006/relationships" xmlns:p="http://schemas.openxmlformats.org/presentationml/2006/main">
+  <p:cSld>
+    <p:spTree>
+      <p:nvGrpSpPr>
+        <p:cNvPr id="1" name="">
+          <a:extLst>
+            <a:ext uri="{FF2B5EF4-FFF2-40B4-BE49-F238E27FC236}">
               <a16:creationId xmlns:a16="http://schemas.microsoft.com/office/drawing/2014/main" id="{6FA076CE-43EE-45FC-1924-AECDDD58C2C3}"/>
             </a:ext>
           </a:extLst>
@@ -3882,7 +4158,7 @@
 </p:sld>
 </file>
 
-<file path=ppt/slides/slide3.xml><?xml version="1.0" encoding="utf-8"?>
+<file path=ppt/slides/slide4.xml><?xml version="1.0" encoding="utf-8"?>
 <p:sld xmlns:a="http://schemas.openxmlformats.org/drawingml/2006/main" xmlns:r="http://schemas.openxmlformats.org/officeDocument/2006/relationships" xmlns:p="http://schemas.openxmlformats.org/presentationml/2006/main">
   <p:cSld>
     <p:spTree>
@@ -3890,7 +4166,7 @@
         <p:cNvPr id="1" name="">
           <a:extLst>
             <a:ext uri="{FF2B5EF4-FFF2-40B4-BE49-F238E27FC236}">
-              <a16:creationId xmlns:a16="http://schemas.microsoft.com/office/drawing/2014/main" id="{CD2158CB-32A2-6844-FCEA-CA2E7B158AFE}"/>
+              <a16:creationId xmlns:a16="http://schemas.microsoft.com/office/drawing/2014/main" id="{D3C28139-9B9D-86BC-FC95-C06D75DA4C40}"/>
             </a:ext>
           </a:extLst>
         </p:cNvPr>
@@ -3910,7 +4186,7 @@
           <p:cNvPr id="11" name="Rectangle : coins arrondis 10">
             <a:extLst>
               <a:ext uri="{FF2B5EF4-FFF2-40B4-BE49-F238E27FC236}">
-                <a16:creationId xmlns:a16="http://schemas.microsoft.com/office/drawing/2014/main" id="{D536D175-14D7-2984-EFF7-4253C83EFCC7}"/>
+                <a16:creationId xmlns:a16="http://schemas.microsoft.com/office/drawing/2014/main" id="{D8625B52-06A9-54B4-8402-6181BFF23C40}"/>
               </a:ext>
             </a:extLst>
           </p:cNvPr>
@@ -3971,7 +4247,7 @@
           <p:cNvPr id="13" name="Rectangle : coins arrondis 12">
             <a:extLst>
               <a:ext uri="{FF2B5EF4-FFF2-40B4-BE49-F238E27FC236}">
-                <a16:creationId xmlns:a16="http://schemas.microsoft.com/office/drawing/2014/main" id="{A49689DA-96B8-5FA7-B3EF-DDC266950986}"/>
+                <a16:creationId xmlns:a16="http://schemas.microsoft.com/office/drawing/2014/main" id="{22091C76-A6AA-6226-D37F-EE8389E0BDB2}"/>
               </a:ext>
             </a:extLst>
           </p:cNvPr>
@@ -4032,7 +4308,7 @@
           <p:cNvPr id="14" name="Rectangle : coins arrondis 13">
             <a:extLst>
               <a:ext uri="{FF2B5EF4-FFF2-40B4-BE49-F238E27FC236}">
-                <a16:creationId xmlns:a16="http://schemas.microsoft.com/office/drawing/2014/main" id="{C2312121-8090-A377-8A77-E41BAFEB5DA1}"/>
+                <a16:creationId xmlns:a16="http://schemas.microsoft.com/office/drawing/2014/main" id="{AEA96F91-D910-CD97-F829-1CF2923E2EB1}"/>
               </a:ext>
             </a:extLst>
           </p:cNvPr>
@@ -4091,20 +4367,20 @@
     </p:spTree>
     <p:extLst>
       <p:ext uri="{BB962C8B-B14F-4D97-AF65-F5344CB8AC3E}">
-        <p14:creationId xmlns:p14="http://schemas.microsoft.com/office/powerpoint/2010/main" val="1029189622"/>
+        <p14:creationId xmlns:p14="http://schemas.microsoft.com/office/powerpoint/2010/main" val="2500591958"/>
       </p:ext>
     </p:extLst>
   </p:cSld>
   <p:clrMapOvr>
     <a:masterClrMapping/>
   </p:clrMapOvr>
-  <mc:AlternateContent xmlns:mc="http://schemas.openxmlformats.org/markup-compatibility/2006" xmlns:p159="http://schemas.microsoft.com/office/powerpoint/2015/09/main">
-    <mc:Choice Requires="p159">
+  <mc:AlternateContent xmlns:mc="http://schemas.openxmlformats.org/markup-compatibility/2006">
+    <mc:Choice xmlns:p159="http://schemas.microsoft.com/office/powerpoint/2015/09/main" Requires="p159">
       <p:transition spd="med">
         <p159:morph option="byObject"/>
       </p:transition>
     </mc:Choice>
-    <mc:Fallback xmlns="">
+    <mc:Fallback>
       <p:transition spd="med">
         <p:fade/>
       </p:transition>
@@ -4113,7 +4389,7 @@
 </p:sld>
 </file>
 
-<file path=ppt/slides/slide4.xml><?xml version="1.0" encoding="utf-8"?>
+<file path=ppt/slides/slide5.xml><?xml version="1.0" encoding="utf-8"?>
 <p:sld xmlns:a="http://schemas.openxmlformats.org/drawingml/2006/main" xmlns:r="http://schemas.openxmlformats.org/officeDocument/2006/relationships" xmlns:p="http://schemas.openxmlformats.org/presentationml/2006/main">
   <p:cSld>
     <p:spTree>

</xml_diff>

<commit_message>
Adjust storage DEBUG, update bot, metadata & deps
Multiple changes across the project:

- storage: changed DEBUG env default checks in StorageService.append and module-level append so writes are skipped when DEBUG is not set (env.get default changed from "1" to "0").
- scripts/selenium_bot.py: updated BASE_URL to http://localhost:7860, adjusted logging/config formatting and refactored many execute_script/driver calls for clearer multi-line arguments and better readability; minor logging message formatting changes.
- pyproject.toml: updated package description.
- README.md: replaced single-line README with YAML frontmatter and expanded header metadata.
- run.py: added import os.
- requirements.txt: removed (deleted).
- Binary presentation file updated (Présentation_orale.pptx).

These edits are primarily configuration, formatting and behavioral tweaks (notable: storage write behavior and bot target port).
</commit_message>
<xml_diff>
--- a/Présentation_orale.pptx
+++ b/Présentation_orale.pptx
@@ -5,11 +5,13 @@
     <p:sldMasterId id="2147483648" r:id="rId1"/>
   </p:sldMasterIdLst>
   <p:sldIdLst>
-    <p:sldId id="256" r:id="rId2"/>
-    <p:sldId id="258" r:id="rId3"/>
-    <p:sldId id="257" r:id="rId4"/>
-    <p:sldId id="260" r:id="rId5"/>
-    <p:sldId id="259" r:id="rId6"/>
+    <p:sldId id="262" r:id="rId2"/>
+    <p:sldId id="256" r:id="rId3"/>
+    <p:sldId id="258" r:id="rId4"/>
+    <p:sldId id="261" r:id="rId5"/>
+    <p:sldId id="257" r:id="rId6"/>
+    <p:sldId id="260" r:id="rId7"/>
+    <p:sldId id="259" r:id="rId8"/>
   </p:sldIdLst>
   <p:sldSz cx="12192000" cy="6858000"/>
   <p:notesSz cx="6858000" cy="9144000"/>
@@ -3321,6 +3323,445 @@
   <p:cSld>
     <p:spTree>
       <p:nvGrpSpPr>
+        <p:cNvPr id="1" name="">
+          <a:extLst>
+            <a:ext uri="{FF2B5EF4-FFF2-40B4-BE49-F238E27FC236}">
+              <a16:creationId xmlns:a16="http://schemas.microsoft.com/office/drawing/2014/main" id="{02DD03A9-014E-7772-E539-6DD3E4AE8406}"/>
+            </a:ext>
+          </a:extLst>
+        </p:cNvPr>
+        <p:cNvGrpSpPr/>
+        <p:nvPr/>
+      </p:nvGrpSpPr>
+      <p:grpSpPr>
+        <a:xfrm>
+          <a:off x="0" y="0"/>
+          <a:ext cx="0" cy="0"/>
+          <a:chOff x="0" y="0"/>
+          <a:chExt cx="0" cy="0"/>
+        </a:xfrm>
+      </p:grpSpPr>
+      <p:sp>
+        <p:nvSpPr>
+          <p:cNvPr id="2" name="Rectangle 1">
+            <a:extLst>
+              <a:ext uri="{FF2B5EF4-FFF2-40B4-BE49-F238E27FC236}">
+                <a16:creationId xmlns:a16="http://schemas.microsoft.com/office/drawing/2014/main" id="{437FBDAA-B45C-FC44-8130-FDD923565EFF}"/>
+              </a:ext>
+            </a:extLst>
+          </p:cNvPr>
+          <p:cNvSpPr/>
+          <p:nvPr/>
+        </p:nvSpPr>
+        <p:spPr>
+          <a:xfrm>
+            <a:off x="0" y="1"/>
+            <a:ext cx="6794090" cy="6858000"/>
+          </a:xfrm>
+          <a:prstGeom prst="rect">
+            <a:avLst/>
+          </a:prstGeom>
+          <a:solidFill>
+            <a:srgbClr val="FF9A00"/>
+          </a:solidFill>
+          <a:ln>
+            <a:noFill/>
+          </a:ln>
+        </p:spPr>
+        <p:style>
+          <a:lnRef idx="2">
+            <a:schemeClr val="accent1">
+              <a:shade val="15000"/>
+            </a:schemeClr>
+          </a:lnRef>
+          <a:fillRef idx="1">
+            <a:schemeClr val="accent1"/>
+          </a:fillRef>
+          <a:effectRef idx="0">
+            <a:schemeClr val="accent1"/>
+          </a:effectRef>
+          <a:fontRef idx="minor">
+            <a:schemeClr val="lt1"/>
+          </a:fontRef>
+        </p:style>
+        <p:txBody>
+          <a:bodyPr rtlCol="0" anchor="ctr"/>
+          <a:lstStyle/>
+          <a:p>
+            <a:pPr algn="ctr"/>
+            <a:endParaRPr lang="fr-FR"/>
+          </a:p>
+        </p:txBody>
+      </p:sp>
+      <p:sp>
+        <p:nvSpPr>
+          <p:cNvPr id="3" name="ZoneTexte 2">
+            <a:extLst>
+              <a:ext uri="{FF2B5EF4-FFF2-40B4-BE49-F238E27FC236}">
+                <a16:creationId xmlns:a16="http://schemas.microsoft.com/office/drawing/2014/main" id="{ABED3869-FDFA-C579-A8CF-1C8724B7C289}"/>
+              </a:ext>
+            </a:extLst>
+          </p:cNvPr>
+          <p:cNvSpPr txBox="1"/>
+          <p:nvPr/>
+        </p:nvSpPr>
+        <p:spPr>
+          <a:xfrm>
+            <a:off x="761097" y="1808446"/>
+            <a:ext cx="9340645" cy="1200329"/>
+          </a:xfrm>
+          <a:prstGeom prst="rect">
+            <a:avLst/>
+          </a:prstGeom>
+          <a:noFill/>
+          <a:ln w="47625">
+            <a:solidFill>
+              <a:schemeClr val="tx1"/>
+            </a:solidFill>
+          </a:ln>
+        </p:spPr>
+        <p:txBody>
+          <a:bodyPr wrap="square" rtlCol="0">
+            <a:spAutoFit/>
+          </a:bodyPr>
+          <a:lstStyle/>
+          <a:p>
+            <a:r>
+              <a:rPr lang="fr-FR" sz="7200" dirty="0">
+                <a:latin typeface="Abadi" panose="020B0604020104020204" pitchFamily="34" charset="0"/>
+              </a:rPr>
+              <a:t>Challenge Web Mining</a:t>
+            </a:r>
+          </a:p>
+        </p:txBody>
+      </p:sp>
+      <p:pic>
+        <p:nvPicPr>
+          <p:cNvPr id="4" name="Picture 2">
+            <a:extLst>
+              <a:ext uri="{FF2B5EF4-FFF2-40B4-BE49-F238E27FC236}">
+                <a16:creationId xmlns:a16="http://schemas.microsoft.com/office/drawing/2014/main" id="{FDE91B8F-5FA4-9E45-F1AF-249E48EDAB05}"/>
+              </a:ext>
+            </a:extLst>
+          </p:cNvPr>
+          <p:cNvPicPr>
+            <a:picLocks noChangeAspect="1" noChangeArrowheads="1"/>
+          </p:cNvPicPr>
+          <p:nvPr/>
+        </p:nvPicPr>
+        <p:blipFill>
+          <a:blip r:embed="rId2">
+            <a:extLst>
+              <a:ext uri="{28A0092B-C50C-407E-A947-70E740481C1C}">
+                <a14:useLocalDpi xmlns:a14="http://schemas.microsoft.com/office/drawing/2010/main" val="0"/>
+              </a:ext>
+            </a:extLst>
+          </a:blip>
+          <a:srcRect/>
+          <a:stretch>
+            <a:fillRect/>
+          </a:stretch>
+        </p:blipFill>
+        <p:spPr bwMode="auto">
+          <a:xfrm>
+            <a:off x="0" y="5134611"/>
+            <a:ext cx="3215481" cy="1723389"/>
+          </a:xfrm>
+          <a:prstGeom prst="rect">
+            <a:avLst/>
+          </a:prstGeom>
+          <a:noFill/>
+          <a:extLst>
+            <a:ext uri="{909E8E84-426E-40DD-AFC4-6F175D3DCCD1}">
+              <a14:hiddenFill xmlns:a14="http://schemas.microsoft.com/office/drawing/2010/main">
+                <a:solidFill>
+                  <a:srgbClr val="FFFFFF"/>
+                </a:solidFill>
+              </a14:hiddenFill>
+            </a:ext>
+          </a:extLst>
+        </p:spPr>
+      </p:pic>
+      <p:sp>
+        <p:nvSpPr>
+          <p:cNvPr id="5" name="ZoneTexte 4">
+            <a:extLst>
+              <a:ext uri="{FF2B5EF4-FFF2-40B4-BE49-F238E27FC236}">
+                <a16:creationId xmlns:a16="http://schemas.microsoft.com/office/drawing/2014/main" id="{0E46E25E-1C8B-974A-2ECE-92B9DA71814F}"/>
+              </a:ext>
+            </a:extLst>
+          </p:cNvPr>
+          <p:cNvSpPr txBox="1"/>
+          <p:nvPr/>
+        </p:nvSpPr>
+        <p:spPr>
+          <a:xfrm>
+            <a:off x="9259746" y="5534640"/>
+            <a:ext cx="2673753" cy="923330"/>
+          </a:xfrm>
+          <a:prstGeom prst="rect">
+            <a:avLst/>
+          </a:prstGeom>
+          <a:noFill/>
+        </p:spPr>
+        <p:txBody>
+          <a:bodyPr wrap="square" rtlCol="0">
+            <a:spAutoFit/>
+          </a:bodyPr>
+          <a:lstStyle/>
+          <a:p>
+            <a:pPr algn="r"/>
+            <a:r>
+              <a:rPr lang="fr-FR" dirty="0"/>
+              <a:t>Olivier BOROT</a:t>
+            </a:r>
+          </a:p>
+          <a:p>
+            <a:pPr algn="r"/>
+            <a:r>
+              <a:rPr lang="fr-FR" dirty="0"/>
+              <a:t> Marin NAGY</a:t>
+            </a:r>
+          </a:p>
+          <a:p>
+            <a:pPr algn="r"/>
+            <a:r>
+              <a:rPr lang="fr-FR" dirty="0"/>
+              <a:t>  Léo-Paul </a:t>
+            </a:r>
+            <a:r>
+              <a:rPr lang="fr-FR" dirty="0" err="1"/>
+              <a:t>Knoepffler</a:t>
+            </a:r>
+            <a:endParaRPr lang="fr-FR" dirty="0"/>
+          </a:p>
+        </p:txBody>
+      </p:sp>
+      <p:sp>
+        <p:nvSpPr>
+          <p:cNvPr id="6" name="ZoneTexte 5">
+            <a:extLst>
+              <a:ext uri="{FF2B5EF4-FFF2-40B4-BE49-F238E27FC236}">
+                <a16:creationId xmlns:a16="http://schemas.microsoft.com/office/drawing/2014/main" id="{880E0E0C-53C0-B161-3D19-8F6A3F08CD9E}"/>
+              </a:ext>
+            </a:extLst>
+          </p:cNvPr>
+          <p:cNvSpPr txBox="1"/>
+          <p:nvPr/>
+        </p:nvSpPr>
+        <p:spPr>
+          <a:xfrm>
+            <a:off x="8866208" y="5134611"/>
+            <a:ext cx="3067291" cy="369332"/>
+          </a:xfrm>
+          <a:prstGeom prst="rect">
+            <a:avLst/>
+          </a:prstGeom>
+          <a:noFill/>
+        </p:spPr>
+        <p:txBody>
+          <a:bodyPr wrap="square" rtlCol="0">
+            <a:spAutoFit/>
+          </a:bodyPr>
+          <a:lstStyle/>
+          <a:p>
+            <a:pPr algn="r"/>
+            <a:r>
+              <a:rPr lang="fr-FR" dirty="0"/>
+              <a:t>Master 2 SISE – Mars 2026</a:t>
+            </a:r>
+          </a:p>
+        </p:txBody>
+      </p:sp>
+      <p:sp>
+        <p:nvSpPr>
+          <p:cNvPr id="10" name="ZoneTexte 9">
+            <a:extLst>
+              <a:ext uri="{FF2B5EF4-FFF2-40B4-BE49-F238E27FC236}">
+                <a16:creationId xmlns:a16="http://schemas.microsoft.com/office/drawing/2014/main" id="{25503320-C6F5-C7DE-B803-9C50AFF8A583}"/>
+              </a:ext>
+            </a:extLst>
+          </p:cNvPr>
+          <p:cNvSpPr txBox="1"/>
+          <p:nvPr/>
+        </p:nvSpPr>
+        <p:spPr>
+          <a:xfrm>
+            <a:off x="735667" y="3290187"/>
+            <a:ext cx="5972538" cy="1569660"/>
+          </a:xfrm>
+          <a:prstGeom prst="rect">
+            <a:avLst/>
+          </a:prstGeom>
+          <a:noFill/>
+          <a:ln w="47625">
+            <a:noFill/>
+          </a:ln>
+        </p:spPr>
+        <p:txBody>
+          <a:bodyPr wrap="square" rtlCol="0">
+            <a:spAutoFit/>
+          </a:bodyPr>
+          <a:lstStyle>
+            <a:defPPr>
+              <a:defRPr lang="fr-FR"/>
+            </a:defPPr>
+            <a:lvl1pPr>
+              <a:defRPr sz="7200">
+                <a:latin typeface="Abadi" panose="020B0604020104020204" pitchFamily="34" charset="0"/>
+              </a:defRPr>
+            </a:lvl1pPr>
+          </a:lstStyle>
+          <a:p>
+            <a:r>
+              <a:rPr lang="fr-FR" sz="3200" dirty="0"/>
+              <a:t>Analyses des comportements via les mouvements de souris sur un site marchand</a:t>
+            </a:r>
+          </a:p>
+        </p:txBody>
+      </p:sp>
+      <p:grpSp>
+        <p:nvGrpSpPr>
+          <p:cNvPr id="7" name="Groupe 6">
+            <a:extLst>
+              <a:ext uri="{FF2B5EF4-FFF2-40B4-BE49-F238E27FC236}">
+                <a16:creationId xmlns:a16="http://schemas.microsoft.com/office/drawing/2014/main" id="{26AED1F9-2FD9-5AD9-E5ED-051B54B567E6}"/>
+              </a:ext>
+            </a:extLst>
+          </p:cNvPr>
+          <p:cNvGrpSpPr/>
+          <p:nvPr/>
+        </p:nvGrpSpPr>
+        <p:grpSpPr>
+          <a:xfrm>
+            <a:off x="6991109" y="3283538"/>
+            <a:ext cx="4942390" cy="1576309"/>
+            <a:chOff x="6886937" y="3240911"/>
+            <a:chExt cx="4942390" cy="1576309"/>
+          </a:xfrm>
+        </p:grpSpPr>
+        <p:sp>
+          <p:nvSpPr>
+            <p:cNvPr id="8" name="Rectangle : coins arrondis 7">
+              <a:extLst>
+                <a:ext uri="{FF2B5EF4-FFF2-40B4-BE49-F238E27FC236}">
+                  <a16:creationId xmlns:a16="http://schemas.microsoft.com/office/drawing/2014/main" id="{1013C9FF-0EC3-ECD0-3F93-9FA93B0BBFBF}"/>
+                </a:ext>
+              </a:extLst>
+            </p:cNvPr>
+            <p:cNvSpPr/>
+            <p:nvPr/>
+          </p:nvSpPr>
+          <p:spPr>
+            <a:xfrm>
+              <a:off x="6886937" y="3240911"/>
+              <a:ext cx="4942390" cy="1576309"/>
+            </a:xfrm>
+            <a:prstGeom prst="roundRect">
+              <a:avLst>
+                <a:gd name="adj" fmla="val 11658"/>
+              </a:avLst>
+            </a:prstGeom>
+            <a:solidFill>
+              <a:srgbClr val="0070C0"/>
+            </a:solidFill>
+            <a:ln>
+              <a:noFill/>
+            </a:ln>
+          </p:spPr>
+          <p:style>
+            <a:lnRef idx="2">
+              <a:schemeClr val="accent1">
+                <a:shade val="15000"/>
+              </a:schemeClr>
+            </a:lnRef>
+            <a:fillRef idx="1">
+              <a:schemeClr val="accent1"/>
+            </a:fillRef>
+            <a:effectRef idx="0">
+              <a:schemeClr val="accent1"/>
+            </a:effectRef>
+            <a:fontRef idx="minor">
+              <a:schemeClr val="lt1"/>
+            </a:fontRef>
+          </p:style>
+          <p:txBody>
+            <a:bodyPr rtlCol="0" anchor="ctr"/>
+            <a:lstStyle/>
+            <a:p>
+              <a:pPr algn="ctr"/>
+              <a:endParaRPr lang="fr-FR"/>
+            </a:p>
+          </p:txBody>
+        </p:sp>
+        <p:pic>
+          <p:nvPicPr>
+            <p:cNvPr id="9" name="Image 8">
+              <a:extLst>
+                <a:ext uri="{FF2B5EF4-FFF2-40B4-BE49-F238E27FC236}">
+                  <a16:creationId xmlns:a16="http://schemas.microsoft.com/office/drawing/2014/main" id="{7457B7A1-A555-3E87-A184-4BDEF02DB872}"/>
+                </a:ext>
+              </a:extLst>
+            </p:cNvPr>
+            <p:cNvPicPr>
+              <a:picLocks noChangeAspect="1"/>
+            </p:cNvPicPr>
+            <p:nvPr/>
+          </p:nvPicPr>
+          <p:blipFill>
+            <a:blip r:embed="rId3">
+              <a:extLst>
+                <a:ext uri="{28A0092B-C50C-407E-A947-70E740481C1C}">
+                  <a14:useLocalDpi xmlns:a14="http://schemas.microsoft.com/office/drawing/2010/main" val="0"/>
+                </a:ext>
+              </a:extLst>
+            </a:blip>
+            <a:stretch>
+              <a:fillRect/>
+            </a:stretch>
+          </p:blipFill>
+          <p:spPr>
+            <a:xfrm>
+              <a:off x="7029548" y="3363413"/>
+              <a:ext cx="4657167" cy="1331304"/>
+            </a:xfrm>
+            <a:prstGeom prst="rect">
+              <a:avLst/>
+            </a:prstGeom>
+            <a:noFill/>
+          </p:spPr>
+        </p:pic>
+      </p:grpSp>
+    </p:spTree>
+    <p:extLst>
+      <p:ext uri="{BB962C8B-B14F-4D97-AF65-F5344CB8AC3E}">
+        <p14:creationId xmlns:p14="http://schemas.microsoft.com/office/powerpoint/2010/main" val="2431942791"/>
+      </p:ext>
+    </p:extLst>
+  </p:cSld>
+  <p:clrMapOvr>
+    <a:masterClrMapping/>
+  </p:clrMapOvr>
+  <mc:AlternateContent xmlns:mc="http://schemas.openxmlformats.org/markup-compatibility/2006">
+    <mc:Choice xmlns:p159="http://schemas.microsoft.com/office/powerpoint/2015/09/main" Requires="p159">
+      <p:transition spd="med">
+        <p159:morph option="byObject"/>
+      </p:transition>
+    </mc:Choice>
+    <mc:Fallback>
+      <p:transition spd="med">
+        <p:fade/>
+      </p:transition>
+    </mc:Fallback>
+  </mc:AlternateContent>
+</p:sld>
+</file>
+
+<file path=ppt/slides/slide2.xml><?xml version="1.0" encoding="utf-8"?>
+<p:sld xmlns:a="http://schemas.openxmlformats.org/drawingml/2006/main" xmlns:r="http://schemas.openxmlformats.org/officeDocument/2006/relationships" xmlns:p="http://schemas.openxmlformats.org/presentationml/2006/main">
+  <p:cSld>
+    <p:spTree>
+      <p:nvGrpSpPr>
         <p:cNvPr id="1" name=""/>
         <p:cNvGrpSpPr/>
         <p:nvPr/>
@@ -3526,7 +3967,7 @@
 </p:sld>
 </file>
 
-<file path=ppt/slides/slide2.xml><?xml version="1.0" encoding="utf-8"?>
+<file path=ppt/slides/slide3.xml><?xml version="1.0" encoding="utf-8"?>
 <p:sld xmlns:a="http://schemas.openxmlformats.org/drawingml/2006/main" xmlns:r="http://schemas.openxmlformats.org/officeDocument/2006/relationships" xmlns:p="http://schemas.openxmlformats.org/presentationml/2006/main">
   <p:cSld>
     <p:spTree>
@@ -3853,7 +4294,446 @@
 </p:sld>
 </file>
 
-<file path=ppt/slides/slide3.xml><?xml version="1.0" encoding="utf-8"?>
+<file path=ppt/slides/slide4.xml><?xml version="1.0" encoding="utf-8"?>
+<p:sld xmlns:a="http://schemas.openxmlformats.org/drawingml/2006/main" xmlns:r="http://schemas.openxmlformats.org/officeDocument/2006/relationships" xmlns:p="http://schemas.openxmlformats.org/presentationml/2006/main">
+  <p:cSld>
+    <p:spTree>
+      <p:nvGrpSpPr>
+        <p:cNvPr id="1" name="">
+          <a:extLst>
+            <a:ext uri="{FF2B5EF4-FFF2-40B4-BE49-F238E27FC236}">
+              <a16:creationId xmlns:a16="http://schemas.microsoft.com/office/drawing/2014/main" id="{B9F6542E-F3C4-1A6A-D653-275192C2EDEE}"/>
+            </a:ext>
+          </a:extLst>
+        </p:cNvPr>
+        <p:cNvGrpSpPr/>
+        <p:nvPr/>
+      </p:nvGrpSpPr>
+      <p:grpSpPr>
+        <a:xfrm>
+          <a:off x="0" y="0"/>
+          <a:ext cx="0" cy="0"/>
+          <a:chOff x="0" y="0"/>
+          <a:chExt cx="0" cy="0"/>
+        </a:xfrm>
+      </p:grpSpPr>
+      <p:sp>
+        <p:nvSpPr>
+          <p:cNvPr id="2" name="Rectangle 1">
+            <a:extLst>
+              <a:ext uri="{FF2B5EF4-FFF2-40B4-BE49-F238E27FC236}">
+                <a16:creationId xmlns:a16="http://schemas.microsoft.com/office/drawing/2014/main" id="{14099FC8-B994-EF56-E637-C0B1673D0B23}"/>
+              </a:ext>
+            </a:extLst>
+          </p:cNvPr>
+          <p:cNvSpPr/>
+          <p:nvPr/>
+        </p:nvSpPr>
+        <p:spPr>
+          <a:xfrm>
+            <a:off x="0" y="1"/>
+            <a:ext cx="6794090" cy="6858000"/>
+          </a:xfrm>
+          <a:prstGeom prst="rect">
+            <a:avLst/>
+          </a:prstGeom>
+          <a:solidFill>
+            <a:srgbClr val="FF9A00"/>
+          </a:solidFill>
+          <a:ln>
+            <a:noFill/>
+          </a:ln>
+        </p:spPr>
+        <p:style>
+          <a:lnRef idx="2">
+            <a:schemeClr val="accent1">
+              <a:shade val="15000"/>
+            </a:schemeClr>
+          </a:lnRef>
+          <a:fillRef idx="1">
+            <a:schemeClr val="accent1"/>
+          </a:fillRef>
+          <a:effectRef idx="0">
+            <a:schemeClr val="accent1"/>
+          </a:effectRef>
+          <a:fontRef idx="minor">
+            <a:schemeClr val="lt1"/>
+          </a:fontRef>
+        </p:style>
+        <p:txBody>
+          <a:bodyPr rtlCol="0" anchor="ctr"/>
+          <a:lstStyle/>
+          <a:p>
+            <a:pPr algn="ctr"/>
+            <a:endParaRPr lang="fr-FR"/>
+          </a:p>
+        </p:txBody>
+      </p:sp>
+      <p:sp>
+        <p:nvSpPr>
+          <p:cNvPr id="3" name="ZoneTexte 2">
+            <a:extLst>
+              <a:ext uri="{FF2B5EF4-FFF2-40B4-BE49-F238E27FC236}">
+                <a16:creationId xmlns:a16="http://schemas.microsoft.com/office/drawing/2014/main" id="{12B708E1-B882-871E-BA5E-97790BAD22A9}"/>
+              </a:ext>
+            </a:extLst>
+          </p:cNvPr>
+          <p:cNvSpPr txBox="1"/>
+          <p:nvPr/>
+        </p:nvSpPr>
+        <p:spPr>
+          <a:xfrm>
+            <a:off x="761097" y="1162643"/>
+            <a:ext cx="9340645" cy="1200329"/>
+          </a:xfrm>
+          <a:prstGeom prst="rect">
+            <a:avLst/>
+          </a:prstGeom>
+          <a:noFill/>
+          <a:ln w="47625">
+            <a:solidFill>
+              <a:schemeClr val="tx1"/>
+            </a:solidFill>
+          </a:ln>
+        </p:spPr>
+        <p:txBody>
+          <a:bodyPr wrap="square" rtlCol="0">
+            <a:spAutoFit/>
+          </a:bodyPr>
+          <a:lstStyle/>
+          <a:p>
+            <a:r>
+              <a:rPr lang="fr-FR" sz="7200" dirty="0">
+                <a:latin typeface="Abadi" panose="020B0604020104020204" pitchFamily="34" charset="0"/>
+              </a:rPr>
+              <a:t>Challenge Web Mining</a:t>
+            </a:r>
+          </a:p>
+        </p:txBody>
+      </p:sp>
+      <p:pic>
+        <p:nvPicPr>
+          <p:cNvPr id="4" name="Picture 2">
+            <a:extLst>
+              <a:ext uri="{FF2B5EF4-FFF2-40B4-BE49-F238E27FC236}">
+                <a16:creationId xmlns:a16="http://schemas.microsoft.com/office/drawing/2014/main" id="{F3432A4B-189F-1ABB-DC62-F5BE29F13087}"/>
+              </a:ext>
+            </a:extLst>
+          </p:cNvPr>
+          <p:cNvPicPr>
+            <a:picLocks noChangeAspect="1" noChangeArrowheads="1"/>
+          </p:cNvPicPr>
+          <p:nvPr/>
+        </p:nvPicPr>
+        <p:blipFill>
+          <a:blip r:embed="rId2">
+            <a:extLst>
+              <a:ext uri="{28A0092B-C50C-407E-A947-70E740481C1C}">
+                <a14:useLocalDpi xmlns:a14="http://schemas.microsoft.com/office/drawing/2010/main" val="0"/>
+              </a:ext>
+            </a:extLst>
+          </a:blip>
+          <a:srcRect/>
+          <a:stretch>
+            <a:fillRect/>
+          </a:stretch>
+        </p:blipFill>
+        <p:spPr bwMode="auto">
+          <a:xfrm>
+            <a:off x="0" y="5134611"/>
+            <a:ext cx="3215481" cy="1723389"/>
+          </a:xfrm>
+          <a:prstGeom prst="rect">
+            <a:avLst/>
+          </a:prstGeom>
+          <a:noFill/>
+          <a:extLst>
+            <a:ext uri="{909E8E84-426E-40DD-AFC4-6F175D3DCCD1}">
+              <a14:hiddenFill xmlns:a14="http://schemas.microsoft.com/office/drawing/2010/main">
+                <a:solidFill>
+                  <a:srgbClr val="FFFFFF"/>
+                </a:solidFill>
+              </a14:hiddenFill>
+            </a:ext>
+          </a:extLst>
+        </p:spPr>
+      </p:pic>
+      <p:sp>
+        <p:nvSpPr>
+          <p:cNvPr id="5" name="ZoneTexte 4">
+            <a:extLst>
+              <a:ext uri="{FF2B5EF4-FFF2-40B4-BE49-F238E27FC236}">
+                <a16:creationId xmlns:a16="http://schemas.microsoft.com/office/drawing/2014/main" id="{1D0D9F6B-136D-30AD-9DFA-9F514E0022A6}"/>
+              </a:ext>
+            </a:extLst>
+          </p:cNvPr>
+          <p:cNvSpPr txBox="1"/>
+          <p:nvPr/>
+        </p:nvSpPr>
+        <p:spPr>
+          <a:xfrm>
+            <a:off x="9259746" y="5534640"/>
+            <a:ext cx="2673753" cy="923330"/>
+          </a:xfrm>
+          <a:prstGeom prst="rect">
+            <a:avLst/>
+          </a:prstGeom>
+          <a:noFill/>
+        </p:spPr>
+        <p:txBody>
+          <a:bodyPr wrap="square" rtlCol="0">
+            <a:spAutoFit/>
+          </a:bodyPr>
+          <a:lstStyle/>
+          <a:p>
+            <a:pPr algn="r"/>
+            <a:r>
+              <a:rPr lang="fr-FR" dirty="0"/>
+              <a:t>Olivier BOROT</a:t>
+            </a:r>
+          </a:p>
+          <a:p>
+            <a:pPr algn="r"/>
+            <a:r>
+              <a:rPr lang="fr-FR" dirty="0"/>
+              <a:t> Marin NAGY</a:t>
+            </a:r>
+          </a:p>
+          <a:p>
+            <a:pPr algn="r"/>
+            <a:r>
+              <a:rPr lang="fr-FR" dirty="0"/>
+              <a:t>  Léo-Paul </a:t>
+            </a:r>
+            <a:r>
+              <a:rPr lang="fr-FR" dirty="0" err="1"/>
+              <a:t>Knoepffler</a:t>
+            </a:r>
+            <a:endParaRPr lang="fr-FR" dirty="0"/>
+          </a:p>
+        </p:txBody>
+      </p:sp>
+      <p:sp>
+        <p:nvSpPr>
+          <p:cNvPr id="6" name="ZoneTexte 5">
+            <a:extLst>
+              <a:ext uri="{FF2B5EF4-FFF2-40B4-BE49-F238E27FC236}">
+                <a16:creationId xmlns:a16="http://schemas.microsoft.com/office/drawing/2014/main" id="{215B2343-C150-DEAF-560F-0970A3246D83}"/>
+              </a:ext>
+            </a:extLst>
+          </p:cNvPr>
+          <p:cNvSpPr txBox="1"/>
+          <p:nvPr/>
+        </p:nvSpPr>
+        <p:spPr>
+          <a:xfrm>
+            <a:off x="8866208" y="5134611"/>
+            <a:ext cx="3067291" cy="369332"/>
+          </a:xfrm>
+          <a:prstGeom prst="rect">
+            <a:avLst/>
+          </a:prstGeom>
+          <a:noFill/>
+        </p:spPr>
+        <p:txBody>
+          <a:bodyPr wrap="square" rtlCol="0">
+            <a:spAutoFit/>
+          </a:bodyPr>
+          <a:lstStyle/>
+          <a:p>
+            <a:pPr algn="r"/>
+            <a:r>
+              <a:rPr lang="fr-FR" dirty="0"/>
+              <a:t>Master 2 SISE – Mars 2026</a:t>
+            </a:r>
+          </a:p>
+        </p:txBody>
+      </p:sp>
+      <p:sp>
+        <p:nvSpPr>
+          <p:cNvPr id="10" name="ZoneTexte 9">
+            <a:extLst>
+              <a:ext uri="{FF2B5EF4-FFF2-40B4-BE49-F238E27FC236}">
+                <a16:creationId xmlns:a16="http://schemas.microsoft.com/office/drawing/2014/main" id="{A740F137-B7FF-D49C-BC43-239AF21FF15B}"/>
+              </a:ext>
+            </a:extLst>
+          </p:cNvPr>
+          <p:cNvSpPr txBox="1"/>
+          <p:nvPr/>
+        </p:nvSpPr>
+        <p:spPr>
+          <a:xfrm>
+            <a:off x="761097" y="2513655"/>
+            <a:ext cx="5972538" cy="830997"/>
+          </a:xfrm>
+          <a:prstGeom prst="rect">
+            <a:avLst/>
+          </a:prstGeom>
+          <a:noFill/>
+          <a:ln w="47625">
+            <a:noFill/>
+          </a:ln>
+        </p:spPr>
+        <p:txBody>
+          <a:bodyPr wrap="square" rtlCol="0">
+            <a:spAutoFit/>
+          </a:bodyPr>
+          <a:lstStyle>
+            <a:defPPr>
+              <a:defRPr lang="fr-FR"/>
+            </a:defPPr>
+            <a:lvl1pPr>
+              <a:defRPr sz="7200">
+                <a:latin typeface="Abadi" panose="020B0604020104020204" pitchFamily="34" charset="0"/>
+              </a:defRPr>
+            </a:lvl1pPr>
+          </a:lstStyle>
+          <a:p>
+            <a:r>
+              <a:rPr lang="fr-FR" sz="2400" dirty="0"/>
+              <a:t>Analyses des comportements via les mouvements de souris sur un site marchand</a:t>
+            </a:r>
+          </a:p>
+        </p:txBody>
+      </p:sp>
+      <p:grpSp>
+        <p:nvGrpSpPr>
+          <p:cNvPr id="11" name="Groupe 10">
+            <a:extLst>
+              <a:ext uri="{FF2B5EF4-FFF2-40B4-BE49-F238E27FC236}">
+                <a16:creationId xmlns:a16="http://schemas.microsoft.com/office/drawing/2014/main" id="{89C5FBCF-77D9-6841-E2C3-3A8A9D4F53F0}"/>
+              </a:ext>
+            </a:extLst>
+          </p:cNvPr>
+          <p:cNvGrpSpPr/>
+          <p:nvPr/>
+        </p:nvGrpSpPr>
+        <p:grpSpPr>
+          <a:xfrm>
+            <a:off x="6886937" y="3240911"/>
+            <a:ext cx="4942390" cy="1576309"/>
+            <a:chOff x="6886937" y="3240911"/>
+            <a:chExt cx="4942390" cy="1576309"/>
+          </a:xfrm>
+        </p:grpSpPr>
+        <p:sp>
+          <p:nvSpPr>
+            <p:cNvPr id="9" name="Rectangle : coins arrondis 8">
+              <a:extLst>
+                <a:ext uri="{FF2B5EF4-FFF2-40B4-BE49-F238E27FC236}">
+                  <a16:creationId xmlns:a16="http://schemas.microsoft.com/office/drawing/2014/main" id="{1193B3A8-7B67-779F-B89C-CC3A8199D7D8}"/>
+                </a:ext>
+              </a:extLst>
+            </p:cNvPr>
+            <p:cNvSpPr/>
+            <p:nvPr/>
+          </p:nvSpPr>
+          <p:spPr>
+            <a:xfrm>
+              <a:off x="6886937" y="3240911"/>
+              <a:ext cx="4942390" cy="1576309"/>
+            </a:xfrm>
+            <a:prstGeom prst="roundRect">
+              <a:avLst>
+                <a:gd name="adj" fmla="val 11658"/>
+              </a:avLst>
+            </a:prstGeom>
+            <a:solidFill>
+              <a:srgbClr val="0070C0"/>
+            </a:solidFill>
+            <a:ln>
+              <a:noFill/>
+            </a:ln>
+          </p:spPr>
+          <p:style>
+            <a:lnRef idx="2">
+              <a:schemeClr val="accent1">
+                <a:shade val="15000"/>
+              </a:schemeClr>
+            </a:lnRef>
+            <a:fillRef idx="1">
+              <a:schemeClr val="accent1"/>
+            </a:fillRef>
+            <a:effectRef idx="0">
+              <a:schemeClr val="accent1"/>
+            </a:effectRef>
+            <a:fontRef idx="minor">
+              <a:schemeClr val="lt1"/>
+            </a:fontRef>
+          </p:style>
+          <p:txBody>
+            <a:bodyPr rtlCol="0" anchor="ctr"/>
+            <a:lstStyle/>
+            <a:p>
+              <a:pPr algn="ctr"/>
+              <a:endParaRPr lang="fr-FR"/>
+            </a:p>
+          </p:txBody>
+        </p:sp>
+        <p:pic>
+          <p:nvPicPr>
+            <p:cNvPr id="8" name="Image 7">
+              <a:extLst>
+                <a:ext uri="{FF2B5EF4-FFF2-40B4-BE49-F238E27FC236}">
+                  <a16:creationId xmlns:a16="http://schemas.microsoft.com/office/drawing/2014/main" id="{78606527-C64C-7301-B617-2E74FA6C3253}"/>
+                </a:ext>
+              </a:extLst>
+            </p:cNvPr>
+            <p:cNvPicPr>
+              <a:picLocks noChangeAspect="1"/>
+            </p:cNvPicPr>
+            <p:nvPr/>
+          </p:nvPicPr>
+          <p:blipFill>
+            <a:blip r:embed="rId3">
+              <a:extLst>
+                <a:ext uri="{28A0092B-C50C-407E-A947-70E740481C1C}">
+                  <a14:useLocalDpi xmlns:a14="http://schemas.microsoft.com/office/drawing/2010/main" val="0"/>
+                </a:ext>
+              </a:extLst>
+            </a:blip>
+            <a:stretch>
+              <a:fillRect/>
+            </a:stretch>
+          </p:blipFill>
+          <p:spPr>
+            <a:xfrm>
+              <a:off x="7029548" y="3363413"/>
+              <a:ext cx="4657167" cy="1331304"/>
+            </a:xfrm>
+            <a:prstGeom prst="rect">
+              <a:avLst/>
+            </a:prstGeom>
+            <a:noFill/>
+          </p:spPr>
+        </p:pic>
+      </p:grpSp>
+    </p:spTree>
+    <p:extLst>
+      <p:ext uri="{BB962C8B-B14F-4D97-AF65-F5344CB8AC3E}">
+        <p14:creationId xmlns:p14="http://schemas.microsoft.com/office/powerpoint/2010/main" val="4002774859"/>
+      </p:ext>
+    </p:extLst>
+  </p:cSld>
+  <p:clrMapOvr>
+    <a:masterClrMapping/>
+  </p:clrMapOvr>
+  <mc:AlternateContent xmlns:mc="http://schemas.openxmlformats.org/markup-compatibility/2006">
+    <mc:Choice xmlns:p159="http://schemas.microsoft.com/office/powerpoint/2015/09/main" Requires="p159">
+      <p:transition spd="med">
+        <p159:morph option="byObject"/>
+      </p:transition>
+    </mc:Choice>
+    <mc:Fallback>
+      <p:transition spd="med">
+        <p:fade/>
+      </p:transition>
+    </mc:Fallback>
+  </mc:AlternateContent>
+</p:sld>
+</file>
+
+<file path=ppt/slides/slide5.xml><?xml version="1.0" encoding="utf-8"?>
 <p:sld xmlns:a="http://schemas.openxmlformats.org/drawingml/2006/main" xmlns:r="http://schemas.openxmlformats.org/officeDocument/2006/relationships" xmlns:p="http://schemas.openxmlformats.org/presentationml/2006/main">
   <p:cSld>
     <p:spTree>
@@ -4158,7 +5038,7 @@
 </p:sld>
 </file>
 
-<file path=ppt/slides/slide4.xml><?xml version="1.0" encoding="utf-8"?>
+<file path=ppt/slides/slide6.xml><?xml version="1.0" encoding="utf-8"?>
 <p:sld xmlns:a="http://schemas.openxmlformats.org/drawingml/2006/main" xmlns:r="http://schemas.openxmlformats.org/officeDocument/2006/relationships" xmlns:p="http://schemas.openxmlformats.org/presentationml/2006/main">
   <p:cSld>
     <p:spTree>
@@ -4389,7 +5269,7 @@
 </p:sld>
 </file>
 
-<file path=ppt/slides/slide5.xml><?xml version="1.0" encoding="utf-8"?>
+<file path=ppt/slides/slide7.xml><?xml version="1.0" encoding="utf-8"?>
 <p:sld xmlns:a="http://schemas.openxmlformats.org/drawingml/2006/main" xmlns:r="http://schemas.openxmlformats.org/officeDocument/2006/relationships" xmlns:p="http://schemas.openxmlformats.org/presentationml/2006/main">
   <p:cSld>
     <p:spTree>

</xml_diff>